<commit_message>
update code and results
</commit_message>
<xml_diff>
--- a/figures/Supplemental_Figures/Supp_Figure2_case2.pptx
+++ b/figures/Supplemental_Figures/Supp_Figure2_case2.pptx
@@ -2,12 +2,12 @@
 <file path=ppt/presentation.xml><?xml version="1.0" encoding="utf-8"?>
 <p:presentation xmlns:a="http://schemas.openxmlformats.org/drawingml/2006/main" xmlns:r="http://schemas.openxmlformats.org/officeDocument/2006/relationships" xmlns:p="http://schemas.openxmlformats.org/presentationml/2006/main" saveSubsetFonts="1" autoCompressPictures="0">
   <p:sldMasterIdLst>
-    <p:sldMasterId id="2147483708" r:id="rId1"/>
+    <p:sldMasterId id="2147483720" r:id="rId1"/>
   </p:sldMasterIdLst>
   <p:sldIdLst>
     <p:sldId id="256" r:id="rId2"/>
   </p:sldIdLst>
-  <p:sldSz cx="8999538" cy="8640763"/>
+  <p:sldSz cx="12960350" cy="8640763"/>
   <p:notesSz cx="6858000" cy="9144000"/>
   <p:defaultTextStyle>
     <a:defPPr>
@@ -104,6 +104,11 @@
       </a:defRPr>
     </a:lvl9pPr>
   </p:defaultTextStyle>
+  <p:extLst>
+    <p:ext uri="{EFAFB233-063F-42B5-8137-9DF3F51BA10A}">
+      <p15:sldGuideLst xmlns:p15="http://schemas.microsoft.com/office/powerpoint/2012/main"/>
+    </p:ext>
+  </p:extLst>
 </p:presentation>
 </file>
 
@@ -136,15 +141,15 @@
         </p:nvSpPr>
         <p:spPr>
           <a:xfrm>
-            <a:off x="674966" y="1414125"/>
-            <a:ext cx="7649607" cy="3008266"/>
+            <a:off x="972026" y="1414125"/>
+            <a:ext cx="11016298" cy="3008266"/>
           </a:xfrm>
         </p:spPr>
         <p:txBody>
           <a:bodyPr anchor="b"/>
           <a:lstStyle>
             <a:lvl1pPr algn="ctr">
-              <a:defRPr sz="5905"/>
+              <a:defRPr sz="7560"/>
             </a:lvl1pPr>
           </a:lstStyle>
           <a:p>
@@ -168,8 +173,8 @@
         </p:nvSpPr>
         <p:spPr>
           <a:xfrm>
-            <a:off x="1124942" y="4538401"/>
-            <a:ext cx="6749654" cy="2086184"/>
+            <a:off x="1620044" y="4538401"/>
+            <a:ext cx="9720263" cy="2086184"/>
           </a:xfrm>
         </p:spPr>
         <p:txBody>
@@ -177,39 +182,39 @@
           <a:lstStyle>
             <a:lvl1pPr marL="0" indent="0" algn="ctr">
               <a:buNone/>
-              <a:defRPr sz="2362"/>
+              <a:defRPr sz="3024"/>
             </a:lvl1pPr>
-            <a:lvl2pPr marL="449976" indent="0" algn="ctr">
-              <a:buNone/>
-              <a:defRPr sz="1968"/>
+            <a:lvl2pPr marL="576072" indent="0" algn="ctr">
+              <a:buNone/>
+              <a:defRPr sz="2520"/>
             </a:lvl2pPr>
-            <a:lvl3pPr marL="899952" indent="0" algn="ctr">
-              <a:buNone/>
-              <a:defRPr sz="1772"/>
+            <a:lvl3pPr marL="1152144" indent="0" algn="ctr">
+              <a:buNone/>
+              <a:defRPr sz="2268"/>
             </a:lvl3pPr>
-            <a:lvl4pPr marL="1349929" indent="0" algn="ctr">
-              <a:buNone/>
-              <a:defRPr sz="1575"/>
+            <a:lvl4pPr marL="1728216" indent="0" algn="ctr">
+              <a:buNone/>
+              <a:defRPr sz="2016"/>
             </a:lvl4pPr>
-            <a:lvl5pPr marL="1799905" indent="0" algn="ctr">
-              <a:buNone/>
-              <a:defRPr sz="1575"/>
+            <a:lvl5pPr marL="2304288" indent="0" algn="ctr">
+              <a:buNone/>
+              <a:defRPr sz="2016"/>
             </a:lvl5pPr>
-            <a:lvl6pPr marL="2249881" indent="0" algn="ctr">
-              <a:buNone/>
-              <a:defRPr sz="1575"/>
+            <a:lvl6pPr marL="2880360" indent="0" algn="ctr">
+              <a:buNone/>
+              <a:defRPr sz="2016"/>
             </a:lvl6pPr>
-            <a:lvl7pPr marL="2699857" indent="0" algn="ctr">
-              <a:buNone/>
-              <a:defRPr sz="1575"/>
+            <a:lvl7pPr marL="3456432" indent="0" algn="ctr">
+              <a:buNone/>
+              <a:defRPr sz="2016"/>
             </a:lvl7pPr>
-            <a:lvl8pPr marL="3149834" indent="0" algn="ctr">
-              <a:buNone/>
-              <a:defRPr sz="1575"/>
+            <a:lvl8pPr marL="4032504" indent="0" algn="ctr">
+              <a:buNone/>
+              <a:defRPr sz="2016"/>
             </a:lvl8pPr>
-            <a:lvl9pPr marL="3599810" indent="0" algn="ctr">
-              <a:buNone/>
-              <a:defRPr sz="1575"/>
+            <a:lvl9pPr marL="4608576" indent="0" algn="ctr">
+              <a:buNone/>
+              <a:defRPr sz="2016"/>
             </a:lvl9pPr>
           </a:lstStyle>
           <a:p>
@@ -238,7 +243,7 @@
           <a:p>
             <a:fld id="{0234921A-2271-F649-B94C-D9F2E69CC631}" type="datetimeFigureOut">
               <a:rPr lang="en-US" smtClean="0"/>
-              <a:t>7/29/26</a:t>
+              <a:t>8/7/26</a:t>
             </a:fld>
             <a:endParaRPr lang="en-US"/>
           </a:p>
@@ -289,7 +294,7 @@
     </p:spTree>
     <p:extLst>
       <p:ext uri="{BB962C8B-B14F-4D97-AF65-F5344CB8AC3E}">
-        <p14:creationId xmlns:p14="http://schemas.microsoft.com/office/powerpoint/2010/main" val="3203815568"/>
+        <p14:creationId xmlns:p14="http://schemas.microsoft.com/office/powerpoint/2010/main" val="2578101621"/>
       </p:ext>
     </p:extLst>
   </p:cSld>
@@ -408,7 +413,7 @@
           <a:p>
             <a:fld id="{0234921A-2271-F649-B94C-D9F2E69CC631}" type="datetimeFigureOut">
               <a:rPr lang="en-US" smtClean="0"/>
-              <a:t>7/29/26</a:t>
+              <a:t>8/7/26</a:t>
             </a:fld>
             <a:endParaRPr lang="en-US"/>
           </a:p>
@@ -459,7 +464,7 @@
     </p:spTree>
     <p:extLst>
       <p:ext uri="{BB962C8B-B14F-4D97-AF65-F5344CB8AC3E}">
-        <p14:creationId xmlns:p14="http://schemas.microsoft.com/office/powerpoint/2010/main" val="2160792389"/>
+        <p14:creationId xmlns:p14="http://schemas.microsoft.com/office/powerpoint/2010/main" val="885568840"/>
       </p:ext>
     </p:extLst>
   </p:cSld>
@@ -498,8 +503,8 @@
         </p:nvSpPr>
         <p:spPr>
           <a:xfrm>
-            <a:off x="6440295" y="460041"/>
-            <a:ext cx="1940525" cy="7322647"/>
+            <a:off x="9274751" y="460041"/>
+            <a:ext cx="2794575" cy="7322647"/>
           </a:xfrm>
         </p:spPr>
         <p:txBody>
@@ -526,8 +531,8 @@
         </p:nvSpPr>
         <p:spPr>
           <a:xfrm>
-            <a:off x="618719" y="460041"/>
-            <a:ext cx="5709082" cy="7322647"/>
+            <a:off x="891025" y="460041"/>
+            <a:ext cx="8221722" cy="7322647"/>
           </a:xfrm>
         </p:spPr>
         <p:txBody>
@@ -588,7 +593,7 @@
           <a:p>
             <a:fld id="{0234921A-2271-F649-B94C-D9F2E69CC631}" type="datetimeFigureOut">
               <a:rPr lang="en-US" smtClean="0"/>
-              <a:t>7/29/26</a:t>
+              <a:t>8/7/26</a:t>
             </a:fld>
             <a:endParaRPr lang="en-US"/>
           </a:p>
@@ -639,7 +644,7 @@
     </p:spTree>
     <p:extLst>
       <p:ext uri="{BB962C8B-B14F-4D97-AF65-F5344CB8AC3E}">
-        <p14:creationId xmlns:p14="http://schemas.microsoft.com/office/powerpoint/2010/main" val="2546918204"/>
+        <p14:creationId xmlns:p14="http://schemas.microsoft.com/office/powerpoint/2010/main" val="1966168665"/>
       </p:ext>
     </p:extLst>
   </p:cSld>
@@ -758,7 +763,7 @@
           <a:p>
             <a:fld id="{0234921A-2271-F649-B94C-D9F2E69CC631}" type="datetimeFigureOut">
               <a:rPr lang="en-US" smtClean="0"/>
-              <a:t>7/29/26</a:t>
+              <a:t>8/7/26</a:t>
             </a:fld>
             <a:endParaRPr lang="en-US"/>
           </a:p>
@@ -809,7 +814,7 @@
     </p:spTree>
     <p:extLst>
       <p:ext uri="{BB962C8B-B14F-4D97-AF65-F5344CB8AC3E}">
-        <p14:creationId xmlns:p14="http://schemas.microsoft.com/office/powerpoint/2010/main" val="1948778936"/>
+        <p14:creationId xmlns:p14="http://schemas.microsoft.com/office/powerpoint/2010/main" val="1328374543"/>
       </p:ext>
     </p:extLst>
   </p:cSld>
@@ -848,15 +853,15 @@
         </p:nvSpPr>
         <p:spPr>
           <a:xfrm>
-            <a:off x="614031" y="2154193"/>
-            <a:ext cx="7762102" cy="3594317"/>
+            <a:off x="884275" y="2154193"/>
+            <a:ext cx="11178302" cy="3594317"/>
           </a:xfrm>
         </p:spPr>
         <p:txBody>
           <a:bodyPr anchor="b"/>
           <a:lstStyle>
             <a:lvl1pPr>
-              <a:defRPr sz="5905"/>
+              <a:defRPr sz="7560"/>
             </a:lvl1pPr>
           </a:lstStyle>
           <a:p>
@@ -880,8 +885,8 @@
         </p:nvSpPr>
         <p:spPr>
           <a:xfrm>
-            <a:off x="614031" y="5782513"/>
-            <a:ext cx="7762102" cy="1890166"/>
+            <a:off x="884275" y="5782513"/>
+            <a:ext cx="11178302" cy="1890166"/>
           </a:xfrm>
         </p:spPr>
         <p:txBody>
@@ -889,7 +894,7 @@
           <a:lstStyle>
             <a:lvl1pPr marL="0" indent="0">
               <a:buNone/>
-              <a:defRPr sz="2362">
+              <a:defRPr sz="3024">
                 <a:solidFill>
                   <a:schemeClr val="tx1">
                     <a:tint val="82000"/>
@@ -897,9 +902,9 @@
                 </a:solidFill>
               </a:defRPr>
             </a:lvl1pPr>
-            <a:lvl2pPr marL="449976" indent="0">
-              <a:buNone/>
-              <a:defRPr sz="1968">
+            <a:lvl2pPr marL="576072" indent="0">
+              <a:buNone/>
+              <a:defRPr sz="2520">
                 <a:solidFill>
                   <a:schemeClr val="tx1">
                     <a:tint val="82000"/>
@@ -907,9 +912,9 @@
                 </a:solidFill>
               </a:defRPr>
             </a:lvl2pPr>
-            <a:lvl3pPr marL="899952" indent="0">
-              <a:buNone/>
-              <a:defRPr sz="1772">
+            <a:lvl3pPr marL="1152144" indent="0">
+              <a:buNone/>
+              <a:defRPr sz="2268">
                 <a:solidFill>
                   <a:schemeClr val="tx1">
                     <a:tint val="82000"/>
@@ -917,9 +922,9 @@
                 </a:solidFill>
               </a:defRPr>
             </a:lvl3pPr>
-            <a:lvl4pPr marL="1349929" indent="0">
-              <a:buNone/>
-              <a:defRPr sz="1575">
+            <a:lvl4pPr marL="1728216" indent="0">
+              <a:buNone/>
+              <a:defRPr sz="2016">
                 <a:solidFill>
                   <a:schemeClr val="tx1">
                     <a:tint val="82000"/>
@@ -927,9 +932,9 @@
                 </a:solidFill>
               </a:defRPr>
             </a:lvl4pPr>
-            <a:lvl5pPr marL="1799905" indent="0">
-              <a:buNone/>
-              <a:defRPr sz="1575">
+            <a:lvl5pPr marL="2304288" indent="0">
+              <a:buNone/>
+              <a:defRPr sz="2016">
                 <a:solidFill>
                   <a:schemeClr val="tx1">
                     <a:tint val="82000"/>
@@ -937,9 +942,9 @@
                 </a:solidFill>
               </a:defRPr>
             </a:lvl5pPr>
-            <a:lvl6pPr marL="2249881" indent="0">
-              <a:buNone/>
-              <a:defRPr sz="1575">
+            <a:lvl6pPr marL="2880360" indent="0">
+              <a:buNone/>
+              <a:defRPr sz="2016">
                 <a:solidFill>
                   <a:schemeClr val="tx1">
                     <a:tint val="82000"/>
@@ -947,9 +952,9 @@
                 </a:solidFill>
               </a:defRPr>
             </a:lvl6pPr>
-            <a:lvl7pPr marL="2699857" indent="0">
-              <a:buNone/>
-              <a:defRPr sz="1575">
+            <a:lvl7pPr marL="3456432" indent="0">
+              <a:buNone/>
+              <a:defRPr sz="2016">
                 <a:solidFill>
                   <a:schemeClr val="tx1">
                     <a:tint val="82000"/>
@@ -957,9 +962,9 @@
                 </a:solidFill>
               </a:defRPr>
             </a:lvl7pPr>
-            <a:lvl8pPr marL="3149834" indent="0">
-              <a:buNone/>
-              <a:defRPr sz="1575">
+            <a:lvl8pPr marL="4032504" indent="0">
+              <a:buNone/>
+              <a:defRPr sz="2016">
                 <a:solidFill>
                   <a:schemeClr val="tx1">
                     <a:tint val="82000"/>
@@ -967,9 +972,9 @@
                 </a:solidFill>
               </a:defRPr>
             </a:lvl8pPr>
-            <a:lvl9pPr marL="3599810" indent="0">
-              <a:buNone/>
-              <a:defRPr sz="1575">
+            <a:lvl9pPr marL="4608576" indent="0">
+              <a:buNone/>
+              <a:defRPr sz="2016">
                 <a:solidFill>
                   <a:schemeClr val="tx1">
                     <a:tint val="82000"/>
@@ -1004,7 +1009,7 @@
           <a:p>
             <a:fld id="{0234921A-2271-F649-B94C-D9F2E69CC631}" type="datetimeFigureOut">
               <a:rPr lang="en-US" smtClean="0"/>
-              <a:t>7/29/26</a:t>
+              <a:t>8/7/26</a:t>
             </a:fld>
             <a:endParaRPr lang="en-US"/>
           </a:p>
@@ -1055,7 +1060,7 @@
     </p:spTree>
     <p:extLst>
       <p:ext uri="{BB962C8B-B14F-4D97-AF65-F5344CB8AC3E}">
-        <p14:creationId xmlns:p14="http://schemas.microsoft.com/office/powerpoint/2010/main" val="78186382"/>
+        <p14:creationId xmlns:p14="http://schemas.microsoft.com/office/powerpoint/2010/main" val="3961332843"/>
       </p:ext>
     </p:extLst>
   </p:cSld>
@@ -1117,8 +1122,8 @@
         </p:nvSpPr>
         <p:spPr>
           <a:xfrm>
-            <a:off x="618718" y="2300203"/>
-            <a:ext cx="3824804" cy="5482485"/>
+            <a:off x="891024" y="2300203"/>
+            <a:ext cx="5508149" cy="5482485"/>
           </a:xfrm>
         </p:spPr>
         <p:txBody>
@@ -1174,8 +1179,8 @@
         </p:nvSpPr>
         <p:spPr>
           <a:xfrm>
-            <a:off x="4556016" y="2300203"/>
-            <a:ext cx="3824804" cy="5482485"/>
+            <a:off x="6561177" y="2300203"/>
+            <a:ext cx="5508149" cy="5482485"/>
           </a:xfrm>
         </p:spPr>
         <p:txBody>
@@ -1236,7 +1241,7 @@
           <a:p>
             <a:fld id="{0234921A-2271-F649-B94C-D9F2E69CC631}" type="datetimeFigureOut">
               <a:rPr lang="en-US" smtClean="0"/>
-              <a:t>7/29/26</a:t>
+              <a:t>8/7/26</a:t>
             </a:fld>
             <a:endParaRPr lang="en-US"/>
           </a:p>
@@ -1287,7 +1292,7 @@
     </p:spTree>
     <p:extLst>
       <p:ext uri="{BB962C8B-B14F-4D97-AF65-F5344CB8AC3E}">
-        <p14:creationId xmlns:p14="http://schemas.microsoft.com/office/powerpoint/2010/main" val="3454222828"/>
+        <p14:creationId xmlns:p14="http://schemas.microsoft.com/office/powerpoint/2010/main" val="1758678672"/>
       </p:ext>
     </p:extLst>
   </p:cSld>
@@ -1326,8 +1331,8 @@
         </p:nvSpPr>
         <p:spPr>
           <a:xfrm>
-            <a:off x="619890" y="460043"/>
-            <a:ext cx="7762102" cy="1670148"/>
+            <a:off x="892712" y="460043"/>
+            <a:ext cx="11178302" cy="1670148"/>
           </a:xfrm>
         </p:spPr>
         <p:txBody>
@@ -1354,8 +1359,8 @@
         </p:nvSpPr>
         <p:spPr>
           <a:xfrm>
-            <a:off x="619891" y="2118188"/>
-            <a:ext cx="3807226" cy="1038091"/>
+            <a:off x="892713" y="2118188"/>
+            <a:ext cx="5482835" cy="1038091"/>
           </a:xfrm>
         </p:spPr>
         <p:txBody>
@@ -1363,39 +1368,39 @@
           <a:lstStyle>
             <a:lvl1pPr marL="0" indent="0">
               <a:buNone/>
-              <a:defRPr sz="2362" b="1"/>
+              <a:defRPr sz="3024" b="1"/>
             </a:lvl1pPr>
-            <a:lvl2pPr marL="449976" indent="0">
-              <a:buNone/>
-              <a:defRPr sz="1968" b="1"/>
+            <a:lvl2pPr marL="576072" indent="0">
+              <a:buNone/>
+              <a:defRPr sz="2520" b="1"/>
             </a:lvl2pPr>
-            <a:lvl3pPr marL="899952" indent="0">
-              <a:buNone/>
-              <a:defRPr sz="1772" b="1"/>
+            <a:lvl3pPr marL="1152144" indent="0">
+              <a:buNone/>
+              <a:defRPr sz="2268" b="1"/>
             </a:lvl3pPr>
-            <a:lvl4pPr marL="1349929" indent="0">
-              <a:buNone/>
-              <a:defRPr sz="1575" b="1"/>
+            <a:lvl4pPr marL="1728216" indent="0">
+              <a:buNone/>
+              <a:defRPr sz="2016" b="1"/>
             </a:lvl4pPr>
-            <a:lvl5pPr marL="1799905" indent="0">
-              <a:buNone/>
-              <a:defRPr sz="1575" b="1"/>
+            <a:lvl5pPr marL="2304288" indent="0">
+              <a:buNone/>
+              <a:defRPr sz="2016" b="1"/>
             </a:lvl5pPr>
-            <a:lvl6pPr marL="2249881" indent="0">
-              <a:buNone/>
-              <a:defRPr sz="1575" b="1"/>
+            <a:lvl6pPr marL="2880360" indent="0">
+              <a:buNone/>
+              <a:defRPr sz="2016" b="1"/>
             </a:lvl6pPr>
-            <a:lvl7pPr marL="2699857" indent="0">
-              <a:buNone/>
-              <a:defRPr sz="1575" b="1"/>
+            <a:lvl7pPr marL="3456432" indent="0">
+              <a:buNone/>
+              <a:defRPr sz="2016" b="1"/>
             </a:lvl7pPr>
-            <a:lvl8pPr marL="3149834" indent="0">
-              <a:buNone/>
-              <a:defRPr sz="1575" b="1"/>
+            <a:lvl8pPr marL="4032504" indent="0">
+              <a:buNone/>
+              <a:defRPr sz="2016" b="1"/>
             </a:lvl8pPr>
-            <a:lvl9pPr marL="3599810" indent="0">
-              <a:buNone/>
-              <a:defRPr sz="1575" b="1"/>
+            <a:lvl9pPr marL="4608576" indent="0">
+              <a:buNone/>
+              <a:defRPr sz="2016" b="1"/>
             </a:lvl9pPr>
           </a:lstStyle>
           <a:p>
@@ -1419,8 +1424,8 @@
         </p:nvSpPr>
         <p:spPr>
           <a:xfrm>
-            <a:off x="619891" y="3156278"/>
-            <a:ext cx="3807226" cy="4642411"/>
+            <a:off x="892713" y="3156278"/>
+            <a:ext cx="5482835" cy="4642411"/>
           </a:xfrm>
         </p:spPr>
         <p:txBody>
@@ -1476,8 +1481,8 @@
         </p:nvSpPr>
         <p:spPr>
           <a:xfrm>
-            <a:off x="4556017" y="2118188"/>
-            <a:ext cx="3825976" cy="1038091"/>
+            <a:off x="6561178" y="2118188"/>
+            <a:ext cx="5509837" cy="1038091"/>
           </a:xfrm>
         </p:spPr>
         <p:txBody>
@@ -1485,39 +1490,39 @@
           <a:lstStyle>
             <a:lvl1pPr marL="0" indent="0">
               <a:buNone/>
-              <a:defRPr sz="2362" b="1"/>
+              <a:defRPr sz="3024" b="1"/>
             </a:lvl1pPr>
-            <a:lvl2pPr marL="449976" indent="0">
-              <a:buNone/>
-              <a:defRPr sz="1968" b="1"/>
+            <a:lvl2pPr marL="576072" indent="0">
+              <a:buNone/>
+              <a:defRPr sz="2520" b="1"/>
             </a:lvl2pPr>
-            <a:lvl3pPr marL="899952" indent="0">
-              <a:buNone/>
-              <a:defRPr sz="1772" b="1"/>
+            <a:lvl3pPr marL="1152144" indent="0">
+              <a:buNone/>
+              <a:defRPr sz="2268" b="1"/>
             </a:lvl3pPr>
-            <a:lvl4pPr marL="1349929" indent="0">
-              <a:buNone/>
-              <a:defRPr sz="1575" b="1"/>
+            <a:lvl4pPr marL="1728216" indent="0">
+              <a:buNone/>
+              <a:defRPr sz="2016" b="1"/>
             </a:lvl4pPr>
-            <a:lvl5pPr marL="1799905" indent="0">
-              <a:buNone/>
-              <a:defRPr sz="1575" b="1"/>
+            <a:lvl5pPr marL="2304288" indent="0">
+              <a:buNone/>
+              <a:defRPr sz="2016" b="1"/>
             </a:lvl5pPr>
-            <a:lvl6pPr marL="2249881" indent="0">
-              <a:buNone/>
-              <a:defRPr sz="1575" b="1"/>
+            <a:lvl6pPr marL="2880360" indent="0">
+              <a:buNone/>
+              <a:defRPr sz="2016" b="1"/>
             </a:lvl6pPr>
-            <a:lvl7pPr marL="2699857" indent="0">
-              <a:buNone/>
-              <a:defRPr sz="1575" b="1"/>
+            <a:lvl7pPr marL="3456432" indent="0">
+              <a:buNone/>
+              <a:defRPr sz="2016" b="1"/>
             </a:lvl7pPr>
-            <a:lvl8pPr marL="3149834" indent="0">
-              <a:buNone/>
-              <a:defRPr sz="1575" b="1"/>
+            <a:lvl8pPr marL="4032504" indent="0">
+              <a:buNone/>
+              <a:defRPr sz="2016" b="1"/>
             </a:lvl8pPr>
-            <a:lvl9pPr marL="3599810" indent="0">
-              <a:buNone/>
-              <a:defRPr sz="1575" b="1"/>
+            <a:lvl9pPr marL="4608576" indent="0">
+              <a:buNone/>
+              <a:defRPr sz="2016" b="1"/>
             </a:lvl9pPr>
           </a:lstStyle>
           <a:p>
@@ -1541,8 +1546,8 @@
         </p:nvSpPr>
         <p:spPr>
           <a:xfrm>
-            <a:off x="4556017" y="3156278"/>
-            <a:ext cx="3825976" cy="4642411"/>
+            <a:off x="6561178" y="3156278"/>
+            <a:ext cx="5509837" cy="4642411"/>
           </a:xfrm>
         </p:spPr>
         <p:txBody>
@@ -1603,7 +1608,7 @@
           <a:p>
             <a:fld id="{0234921A-2271-F649-B94C-D9F2E69CC631}" type="datetimeFigureOut">
               <a:rPr lang="en-US" smtClean="0"/>
-              <a:t>7/29/26</a:t>
+              <a:t>8/7/26</a:t>
             </a:fld>
             <a:endParaRPr lang="en-US"/>
           </a:p>
@@ -1654,7 +1659,7 @@
     </p:spTree>
     <p:extLst>
       <p:ext uri="{BB962C8B-B14F-4D97-AF65-F5344CB8AC3E}">
-        <p14:creationId xmlns:p14="http://schemas.microsoft.com/office/powerpoint/2010/main" val="3895059644"/>
+        <p14:creationId xmlns:p14="http://schemas.microsoft.com/office/powerpoint/2010/main" val="3530831745"/>
       </p:ext>
     </p:extLst>
   </p:cSld>
@@ -1721,7 +1726,7 @@
           <a:p>
             <a:fld id="{0234921A-2271-F649-B94C-D9F2E69CC631}" type="datetimeFigureOut">
               <a:rPr lang="en-US" smtClean="0"/>
-              <a:t>7/29/26</a:t>
+              <a:t>8/7/26</a:t>
             </a:fld>
             <a:endParaRPr lang="en-US"/>
           </a:p>
@@ -1772,7 +1777,7 @@
     </p:spTree>
     <p:extLst>
       <p:ext uri="{BB962C8B-B14F-4D97-AF65-F5344CB8AC3E}">
-        <p14:creationId xmlns:p14="http://schemas.microsoft.com/office/powerpoint/2010/main" val="802871680"/>
+        <p14:creationId xmlns:p14="http://schemas.microsoft.com/office/powerpoint/2010/main" val="1631356897"/>
       </p:ext>
     </p:extLst>
   </p:cSld>
@@ -1816,7 +1821,7 @@
           <a:p>
             <a:fld id="{0234921A-2271-F649-B94C-D9F2E69CC631}" type="datetimeFigureOut">
               <a:rPr lang="en-US" smtClean="0"/>
-              <a:t>7/29/26</a:t>
+              <a:t>8/7/26</a:t>
             </a:fld>
             <a:endParaRPr lang="en-US"/>
           </a:p>
@@ -1867,7 +1872,7 @@
     </p:spTree>
     <p:extLst>
       <p:ext uri="{BB962C8B-B14F-4D97-AF65-F5344CB8AC3E}">
-        <p14:creationId xmlns:p14="http://schemas.microsoft.com/office/powerpoint/2010/main" val="1517839034"/>
+        <p14:creationId xmlns:p14="http://schemas.microsoft.com/office/powerpoint/2010/main" val="384678101"/>
       </p:ext>
     </p:extLst>
   </p:cSld>
@@ -1906,15 +1911,15 @@
         </p:nvSpPr>
         <p:spPr>
           <a:xfrm>
-            <a:off x="619891" y="576051"/>
-            <a:ext cx="2902585" cy="2016178"/>
+            <a:off x="892712" y="576051"/>
+            <a:ext cx="4180050" cy="2016178"/>
           </a:xfrm>
         </p:spPr>
         <p:txBody>
           <a:bodyPr anchor="b"/>
           <a:lstStyle>
             <a:lvl1pPr>
-              <a:defRPr sz="3149"/>
+              <a:defRPr sz="4032"/>
             </a:lvl1pPr>
           </a:lstStyle>
           <a:p>
@@ -1938,39 +1943,39 @@
         </p:nvSpPr>
         <p:spPr>
           <a:xfrm>
-            <a:off x="3825976" y="1244112"/>
-            <a:ext cx="4556016" cy="6140542"/>
+            <a:off x="5509837" y="1244112"/>
+            <a:ext cx="6561177" cy="6140542"/>
           </a:xfrm>
         </p:spPr>
         <p:txBody>
           <a:bodyPr/>
           <a:lstStyle>
             <a:lvl1pPr>
-              <a:defRPr sz="3149"/>
+              <a:defRPr sz="4032"/>
             </a:lvl1pPr>
             <a:lvl2pPr>
-              <a:defRPr sz="2756"/>
+              <a:defRPr sz="3528"/>
             </a:lvl2pPr>
             <a:lvl3pPr>
-              <a:defRPr sz="2362"/>
+              <a:defRPr sz="3024"/>
             </a:lvl3pPr>
             <a:lvl4pPr>
-              <a:defRPr sz="1968"/>
+              <a:defRPr sz="2520"/>
             </a:lvl4pPr>
             <a:lvl5pPr>
-              <a:defRPr sz="1968"/>
+              <a:defRPr sz="2520"/>
             </a:lvl5pPr>
             <a:lvl6pPr>
-              <a:defRPr sz="1968"/>
+              <a:defRPr sz="2520"/>
             </a:lvl6pPr>
             <a:lvl7pPr>
-              <a:defRPr sz="1968"/>
+              <a:defRPr sz="2520"/>
             </a:lvl7pPr>
             <a:lvl8pPr>
-              <a:defRPr sz="1968"/>
+              <a:defRPr sz="2520"/>
             </a:lvl8pPr>
             <a:lvl9pPr>
-              <a:defRPr sz="1968"/>
+              <a:defRPr sz="2520"/>
             </a:lvl9pPr>
           </a:lstStyle>
           <a:p>
@@ -2023,8 +2028,8 @@
         </p:nvSpPr>
         <p:spPr>
           <a:xfrm>
-            <a:off x="619891" y="2592229"/>
-            <a:ext cx="2902585" cy="4802425"/>
+            <a:off x="892712" y="2592229"/>
+            <a:ext cx="4180050" cy="4802425"/>
           </a:xfrm>
         </p:spPr>
         <p:txBody>
@@ -2032,39 +2037,39 @@
           <a:lstStyle>
             <a:lvl1pPr marL="0" indent="0">
               <a:buNone/>
-              <a:defRPr sz="1575"/>
+              <a:defRPr sz="2016"/>
             </a:lvl1pPr>
-            <a:lvl2pPr marL="449976" indent="0">
-              <a:buNone/>
-              <a:defRPr sz="1378"/>
+            <a:lvl2pPr marL="576072" indent="0">
+              <a:buNone/>
+              <a:defRPr sz="1764"/>
             </a:lvl2pPr>
-            <a:lvl3pPr marL="899952" indent="0">
-              <a:buNone/>
-              <a:defRPr sz="1181"/>
+            <a:lvl3pPr marL="1152144" indent="0">
+              <a:buNone/>
+              <a:defRPr sz="1512"/>
             </a:lvl3pPr>
-            <a:lvl4pPr marL="1349929" indent="0">
-              <a:buNone/>
-              <a:defRPr sz="984"/>
+            <a:lvl4pPr marL="1728216" indent="0">
+              <a:buNone/>
+              <a:defRPr sz="1260"/>
             </a:lvl4pPr>
-            <a:lvl5pPr marL="1799905" indent="0">
-              <a:buNone/>
-              <a:defRPr sz="984"/>
+            <a:lvl5pPr marL="2304288" indent="0">
+              <a:buNone/>
+              <a:defRPr sz="1260"/>
             </a:lvl5pPr>
-            <a:lvl6pPr marL="2249881" indent="0">
-              <a:buNone/>
-              <a:defRPr sz="984"/>
+            <a:lvl6pPr marL="2880360" indent="0">
+              <a:buNone/>
+              <a:defRPr sz="1260"/>
             </a:lvl6pPr>
-            <a:lvl7pPr marL="2699857" indent="0">
-              <a:buNone/>
-              <a:defRPr sz="984"/>
+            <a:lvl7pPr marL="3456432" indent="0">
+              <a:buNone/>
+              <a:defRPr sz="1260"/>
             </a:lvl7pPr>
-            <a:lvl8pPr marL="3149834" indent="0">
-              <a:buNone/>
-              <a:defRPr sz="984"/>
+            <a:lvl8pPr marL="4032504" indent="0">
+              <a:buNone/>
+              <a:defRPr sz="1260"/>
             </a:lvl8pPr>
-            <a:lvl9pPr marL="3599810" indent="0">
-              <a:buNone/>
-              <a:defRPr sz="984"/>
+            <a:lvl9pPr marL="4608576" indent="0">
+              <a:buNone/>
+              <a:defRPr sz="1260"/>
             </a:lvl9pPr>
           </a:lstStyle>
           <a:p>
@@ -2093,7 +2098,7 @@
           <a:p>
             <a:fld id="{0234921A-2271-F649-B94C-D9F2E69CC631}" type="datetimeFigureOut">
               <a:rPr lang="en-US" smtClean="0"/>
-              <a:t>7/29/26</a:t>
+              <a:t>8/7/26</a:t>
             </a:fld>
             <a:endParaRPr lang="en-US"/>
           </a:p>
@@ -2144,7 +2149,7 @@
     </p:spTree>
     <p:extLst>
       <p:ext uri="{BB962C8B-B14F-4D97-AF65-F5344CB8AC3E}">
-        <p14:creationId xmlns:p14="http://schemas.microsoft.com/office/powerpoint/2010/main" val="2174862990"/>
+        <p14:creationId xmlns:p14="http://schemas.microsoft.com/office/powerpoint/2010/main" val="1845146963"/>
       </p:ext>
     </p:extLst>
   </p:cSld>
@@ -2183,15 +2188,15 @@
         </p:nvSpPr>
         <p:spPr>
           <a:xfrm>
-            <a:off x="619891" y="576051"/>
-            <a:ext cx="2902585" cy="2016178"/>
+            <a:off x="892712" y="576051"/>
+            <a:ext cx="4180050" cy="2016178"/>
           </a:xfrm>
         </p:spPr>
         <p:txBody>
           <a:bodyPr anchor="b"/>
           <a:lstStyle>
             <a:lvl1pPr>
-              <a:defRPr sz="3149"/>
+              <a:defRPr sz="4032"/>
             </a:lvl1pPr>
           </a:lstStyle>
           <a:p>
@@ -2215,8 +2220,8 @@
         </p:nvSpPr>
         <p:spPr>
           <a:xfrm>
-            <a:off x="3825976" y="1244112"/>
-            <a:ext cx="4556016" cy="6140542"/>
+            <a:off x="5509837" y="1244112"/>
+            <a:ext cx="6561177" cy="6140542"/>
           </a:xfrm>
         </p:spPr>
         <p:txBody>
@@ -2224,39 +2229,39 @@
           <a:lstStyle>
             <a:lvl1pPr marL="0" indent="0">
               <a:buNone/>
-              <a:defRPr sz="3149"/>
+              <a:defRPr sz="4032"/>
             </a:lvl1pPr>
-            <a:lvl2pPr marL="449976" indent="0">
-              <a:buNone/>
-              <a:defRPr sz="2756"/>
+            <a:lvl2pPr marL="576072" indent="0">
+              <a:buNone/>
+              <a:defRPr sz="3528"/>
             </a:lvl2pPr>
-            <a:lvl3pPr marL="899952" indent="0">
-              <a:buNone/>
-              <a:defRPr sz="2362"/>
+            <a:lvl3pPr marL="1152144" indent="0">
+              <a:buNone/>
+              <a:defRPr sz="3024"/>
             </a:lvl3pPr>
-            <a:lvl4pPr marL="1349929" indent="0">
-              <a:buNone/>
-              <a:defRPr sz="1968"/>
+            <a:lvl4pPr marL="1728216" indent="0">
+              <a:buNone/>
+              <a:defRPr sz="2520"/>
             </a:lvl4pPr>
-            <a:lvl5pPr marL="1799905" indent="0">
-              <a:buNone/>
-              <a:defRPr sz="1968"/>
+            <a:lvl5pPr marL="2304288" indent="0">
+              <a:buNone/>
+              <a:defRPr sz="2520"/>
             </a:lvl5pPr>
-            <a:lvl6pPr marL="2249881" indent="0">
-              <a:buNone/>
-              <a:defRPr sz="1968"/>
+            <a:lvl6pPr marL="2880360" indent="0">
+              <a:buNone/>
+              <a:defRPr sz="2520"/>
             </a:lvl6pPr>
-            <a:lvl7pPr marL="2699857" indent="0">
-              <a:buNone/>
-              <a:defRPr sz="1968"/>
+            <a:lvl7pPr marL="3456432" indent="0">
+              <a:buNone/>
+              <a:defRPr sz="2520"/>
             </a:lvl7pPr>
-            <a:lvl8pPr marL="3149834" indent="0">
-              <a:buNone/>
-              <a:defRPr sz="1968"/>
+            <a:lvl8pPr marL="4032504" indent="0">
+              <a:buNone/>
+              <a:defRPr sz="2520"/>
             </a:lvl8pPr>
-            <a:lvl9pPr marL="3599810" indent="0">
-              <a:buNone/>
-              <a:defRPr sz="1968"/>
+            <a:lvl9pPr marL="4608576" indent="0">
+              <a:buNone/>
+              <a:defRPr sz="2520"/>
             </a:lvl9pPr>
           </a:lstStyle>
           <a:p>
@@ -2280,8 +2285,8 @@
         </p:nvSpPr>
         <p:spPr>
           <a:xfrm>
-            <a:off x="619891" y="2592229"/>
-            <a:ext cx="2902585" cy="4802425"/>
+            <a:off x="892712" y="2592229"/>
+            <a:ext cx="4180050" cy="4802425"/>
           </a:xfrm>
         </p:spPr>
         <p:txBody>
@@ -2289,39 +2294,39 @@
           <a:lstStyle>
             <a:lvl1pPr marL="0" indent="0">
               <a:buNone/>
-              <a:defRPr sz="1575"/>
+              <a:defRPr sz="2016"/>
             </a:lvl1pPr>
-            <a:lvl2pPr marL="449976" indent="0">
-              <a:buNone/>
-              <a:defRPr sz="1378"/>
+            <a:lvl2pPr marL="576072" indent="0">
+              <a:buNone/>
+              <a:defRPr sz="1764"/>
             </a:lvl2pPr>
-            <a:lvl3pPr marL="899952" indent="0">
-              <a:buNone/>
-              <a:defRPr sz="1181"/>
+            <a:lvl3pPr marL="1152144" indent="0">
+              <a:buNone/>
+              <a:defRPr sz="1512"/>
             </a:lvl3pPr>
-            <a:lvl4pPr marL="1349929" indent="0">
-              <a:buNone/>
-              <a:defRPr sz="984"/>
+            <a:lvl4pPr marL="1728216" indent="0">
+              <a:buNone/>
+              <a:defRPr sz="1260"/>
             </a:lvl4pPr>
-            <a:lvl5pPr marL="1799905" indent="0">
-              <a:buNone/>
-              <a:defRPr sz="984"/>
+            <a:lvl5pPr marL="2304288" indent="0">
+              <a:buNone/>
+              <a:defRPr sz="1260"/>
             </a:lvl5pPr>
-            <a:lvl6pPr marL="2249881" indent="0">
-              <a:buNone/>
-              <a:defRPr sz="984"/>
+            <a:lvl6pPr marL="2880360" indent="0">
+              <a:buNone/>
+              <a:defRPr sz="1260"/>
             </a:lvl6pPr>
-            <a:lvl7pPr marL="2699857" indent="0">
-              <a:buNone/>
-              <a:defRPr sz="984"/>
+            <a:lvl7pPr marL="3456432" indent="0">
+              <a:buNone/>
+              <a:defRPr sz="1260"/>
             </a:lvl7pPr>
-            <a:lvl8pPr marL="3149834" indent="0">
-              <a:buNone/>
-              <a:defRPr sz="984"/>
+            <a:lvl8pPr marL="4032504" indent="0">
+              <a:buNone/>
+              <a:defRPr sz="1260"/>
             </a:lvl8pPr>
-            <a:lvl9pPr marL="3599810" indent="0">
-              <a:buNone/>
-              <a:defRPr sz="984"/>
+            <a:lvl9pPr marL="4608576" indent="0">
+              <a:buNone/>
+              <a:defRPr sz="1260"/>
             </a:lvl9pPr>
           </a:lstStyle>
           <a:p>
@@ -2350,7 +2355,7 @@
           <a:p>
             <a:fld id="{0234921A-2271-F649-B94C-D9F2E69CC631}" type="datetimeFigureOut">
               <a:rPr lang="en-US" smtClean="0"/>
-              <a:t>7/29/26</a:t>
+              <a:t>8/7/26</a:t>
             </a:fld>
             <a:endParaRPr lang="en-US"/>
           </a:p>
@@ -2401,7 +2406,7 @@
     </p:spTree>
     <p:extLst>
       <p:ext uri="{BB962C8B-B14F-4D97-AF65-F5344CB8AC3E}">
-        <p14:creationId xmlns:p14="http://schemas.microsoft.com/office/powerpoint/2010/main" val="1179698909"/>
+        <p14:creationId xmlns:p14="http://schemas.microsoft.com/office/powerpoint/2010/main" val="2394910052"/>
       </p:ext>
     </p:extLst>
   </p:cSld>
@@ -2445,8 +2450,8 @@
         </p:nvSpPr>
         <p:spPr>
           <a:xfrm>
-            <a:off x="618718" y="460043"/>
-            <a:ext cx="7762102" cy="1670148"/>
+            <a:off x="891024" y="460043"/>
+            <a:ext cx="11178302" cy="1670148"/>
           </a:xfrm>
           <a:prstGeom prst="rect">
             <a:avLst/>
@@ -2478,8 +2483,8 @@
         </p:nvSpPr>
         <p:spPr>
           <a:xfrm>
-            <a:off x="618718" y="2300203"/>
-            <a:ext cx="7762102" cy="5482485"/>
+            <a:off x="891024" y="2300203"/>
+            <a:ext cx="11178302" cy="5482485"/>
           </a:xfrm>
           <a:prstGeom prst="rect">
             <a:avLst/>
@@ -2540,8 +2545,8 @@
         </p:nvSpPr>
         <p:spPr>
           <a:xfrm>
-            <a:off x="618718" y="8008709"/>
-            <a:ext cx="2024896" cy="460041"/>
+            <a:off x="891024" y="8008709"/>
+            <a:ext cx="2916079" cy="460041"/>
           </a:xfrm>
           <a:prstGeom prst="rect">
             <a:avLst/>
@@ -2551,7 +2556,7 @@
           <a:bodyPr vert="horz" lIns="91440" tIns="45720" rIns="91440" bIns="45720" rtlCol="0" anchor="ctr"/>
           <a:lstStyle>
             <a:lvl1pPr algn="l">
-              <a:defRPr sz="1181">
+              <a:defRPr sz="1512">
                 <a:solidFill>
                   <a:schemeClr val="tx1">
                     <a:tint val="82000"/>
@@ -2563,7 +2568,7 @@
           <a:p>
             <a:fld id="{0234921A-2271-F649-B94C-D9F2E69CC631}" type="datetimeFigureOut">
               <a:rPr lang="en-US" smtClean="0"/>
-              <a:t>7/29/26</a:t>
+              <a:t>8/7/26</a:t>
             </a:fld>
             <a:endParaRPr lang="en-US"/>
           </a:p>
@@ -2581,8 +2586,8 @@
         </p:nvSpPr>
         <p:spPr>
           <a:xfrm>
-            <a:off x="2981097" y="8008709"/>
-            <a:ext cx="3037344" cy="460041"/>
+            <a:off x="4293116" y="8008709"/>
+            <a:ext cx="4374118" cy="460041"/>
           </a:xfrm>
           <a:prstGeom prst="rect">
             <a:avLst/>
@@ -2592,7 +2597,7 @@
           <a:bodyPr vert="horz" lIns="91440" tIns="45720" rIns="91440" bIns="45720" rtlCol="0" anchor="ctr"/>
           <a:lstStyle>
             <a:lvl1pPr algn="ctr">
-              <a:defRPr sz="1181">
+              <a:defRPr sz="1512">
                 <a:solidFill>
                   <a:schemeClr val="tx1">
                     <a:tint val="82000"/>
@@ -2618,8 +2623,8 @@
         </p:nvSpPr>
         <p:spPr>
           <a:xfrm>
-            <a:off x="6355924" y="8008709"/>
-            <a:ext cx="2024896" cy="460041"/>
+            <a:off x="9153247" y="8008709"/>
+            <a:ext cx="2916079" cy="460041"/>
           </a:xfrm>
           <a:prstGeom prst="rect">
             <a:avLst/>
@@ -2629,7 +2634,7 @@
           <a:bodyPr vert="horz" lIns="91440" tIns="45720" rIns="91440" bIns="45720" rtlCol="0" anchor="ctr"/>
           <a:lstStyle>
             <a:lvl1pPr algn="r">
-              <a:defRPr sz="1181">
+              <a:defRPr sz="1512">
                 <a:solidFill>
                   <a:schemeClr val="tx1">
                     <a:tint val="82000"/>
@@ -2650,27 +2655,27 @@
     </p:spTree>
     <p:extLst>
       <p:ext uri="{BB962C8B-B14F-4D97-AF65-F5344CB8AC3E}">
-        <p14:creationId xmlns:p14="http://schemas.microsoft.com/office/powerpoint/2010/main" val="1586213542"/>
+        <p14:creationId xmlns:p14="http://schemas.microsoft.com/office/powerpoint/2010/main" val="706348731"/>
       </p:ext>
     </p:extLst>
   </p:cSld>
   <p:clrMap bg1="lt1" tx1="dk1" bg2="lt2" tx2="dk2" accent1="accent1" accent2="accent2" accent3="accent3" accent4="accent4" accent5="accent5" accent6="accent6" hlink="hlink" folHlink="folHlink"/>
   <p:sldLayoutIdLst>
-    <p:sldLayoutId id="2147483709" r:id="rId1"/>
-    <p:sldLayoutId id="2147483710" r:id="rId2"/>
-    <p:sldLayoutId id="2147483711" r:id="rId3"/>
-    <p:sldLayoutId id="2147483712" r:id="rId4"/>
-    <p:sldLayoutId id="2147483713" r:id="rId5"/>
-    <p:sldLayoutId id="2147483714" r:id="rId6"/>
-    <p:sldLayoutId id="2147483715" r:id="rId7"/>
-    <p:sldLayoutId id="2147483716" r:id="rId8"/>
-    <p:sldLayoutId id="2147483717" r:id="rId9"/>
-    <p:sldLayoutId id="2147483718" r:id="rId10"/>
-    <p:sldLayoutId id="2147483719" r:id="rId11"/>
+    <p:sldLayoutId id="2147483721" r:id="rId1"/>
+    <p:sldLayoutId id="2147483722" r:id="rId2"/>
+    <p:sldLayoutId id="2147483723" r:id="rId3"/>
+    <p:sldLayoutId id="2147483724" r:id="rId4"/>
+    <p:sldLayoutId id="2147483725" r:id="rId5"/>
+    <p:sldLayoutId id="2147483726" r:id="rId6"/>
+    <p:sldLayoutId id="2147483727" r:id="rId7"/>
+    <p:sldLayoutId id="2147483728" r:id="rId8"/>
+    <p:sldLayoutId id="2147483729" r:id="rId9"/>
+    <p:sldLayoutId id="2147483730" r:id="rId10"/>
+    <p:sldLayoutId id="2147483731" r:id="rId11"/>
   </p:sldLayoutIdLst>
   <p:txStyles>
     <p:titleStyle>
-      <a:lvl1pPr algn="l" defTabSz="899952" rtl="0" eaLnBrk="1" latinLnBrk="0" hangingPunct="1">
+      <a:lvl1pPr algn="l" defTabSz="1152144" rtl="0" eaLnBrk="1" latinLnBrk="0" hangingPunct="1">
         <a:lnSpc>
           <a:spcPct val="90000"/>
         </a:lnSpc>
@@ -2678,7 +2683,7 @@
           <a:spcPct val="0"/>
         </a:spcBef>
         <a:buNone/>
-        <a:defRPr sz="4330" kern="1200">
+        <a:defRPr sz="5544" kern="1200">
           <a:solidFill>
             <a:schemeClr val="tx1"/>
           </a:solidFill>
@@ -2689,16 +2694,16 @@
       </a:lvl1pPr>
     </p:titleStyle>
     <p:bodyStyle>
-      <a:lvl1pPr marL="224988" indent="-224988" algn="l" defTabSz="899952" rtl="0" eaLnBrk="1" latinLnBrk="0" hangingPunct="1">
+      <a:lvl1pPr marL="288036" indent="-288036" algn="l" defTabSz="1152144" rtl="0" eaLnBrk="1" latinLnBrk="0" hangingPunct="1">
         <a:lnSpc>
           <a:spcPct val="90000"/>
         </a:lnSpc>
         <a:spcBef>
-          <a:spcPts val="984"/>
+          <a:spcPts val="1260"/>
         </a:spcBef>
         <a:buFont typeface="Arial" panose="020B0604020202020204" pitchFamily="34" charset="0"/>
         <a:buChar char="•"/>
-        <a:defRPr sz="2756" kern="1200">
+        <a:defRPr sz="3528" kern="1200">
           <a:solidFill>
             <a:schemeClr val="tx1"/>
           </a:solidFill>
@@ -2707,16 +2712,16 @@
           <a:cs typeface="+mn-cs"/>
         </a:defRPr>
       </a:lvl1pPr>
-      <a:lvl2pPr marL="674964" indent="-224988" algn="l" defTabSz="899952" rtl="0" eaLnBrk="1" latinLnBrk="0" hangingPunct="1">
+      <a:lvl2pPr marL="864108" indent="-288036" algn="l" defTabSz="1152144" rtl="0" eaLnBrk="1" latinLnBrk="0" hangingPunct="1">
         <a:lnSpc>
           <a:spcPct val="90000"/>
         </a:lnSpc>
         <a:spcBef>
-          <a:spcPts val="492"/>
+          <a:spcPts val="630"/>
         </a:spcBef>
         <a:buFont typeface="Arial" panose="020B0604020202020204" pitchFamily="34" charset="0"/>
         <a:buChar char="•"/>
-        <a:defRPr sz="2362" kern="1200">
+        <a:defRPr sz="3024" kern="1200">
           <a:solidFill>
             <a:schemeClr val="tx1"/>
           </a:solidFill>
@@ -2725,16 +2730,16 @@
           <a:cs typeface="+mn-cs"/>
         </a:defRPr>
       </a:lvl2pPr>
-      <a:lvl3pPr marL="1124941" indent="-224988" algn="l" defTabSz="899952" rtl="0" eaLnBrk="1" latinLnBrk="0" hangingPunct="1">
+      <a:lvl3pPr marL="1440180" indent="-288036" algn="l" defTabSz="1152144" rtl="0" eaLnBrk="1" latinLnBrk="0" hangingPunct="1">
         <a:lnSpc>
           <a:spcPct val="90000"/>
         </a:lnSpc>
         <a:spcBef>
-          <a:spcPts val="492"/>
+          <a:spcPts val="630"/>
         </a:spcBef>
         <a:buFont typeface="Arial" panose="020B0604020202020204" pitchFamily="34" charset="0"/>
         <a:buChar char="•"/>
-        <a:defRPr sz="1968" kern="1200">
+        <a:defRPr sz="2520" kern="1200">
           <a:solidFill>
             <a:schemeClr val="tx1"/>
           </a:solidFill>
@@ -2743,16 +2748,16 @@
           <a:cs typeface="+mn-cs"/>
         </a:defRPr>
       </a:lvl3pPr>
-      <a:lvl4pPr marL="1574917" indent="-224988" algn="l" defTabSz="899952" rtl="0" eaLnBrk="1" latinLnBrk="0" hangingPunct="1">
+      <a:lvl4pPr marL="2016252" indent="-288036" algn="l" defTabSz="1152144" rtl="0" eaLnBrk="1" latinLnBrk="0" hangingPunct="1">
         <a:lnSpc>
           <a:spcPct val="90000"/>
         </a:lnSpc>
         <a:spcBef>
-          <a:spcPts val="492"/>
+          <a:spcPts val="630"/>
         </a:spcBef>
         <a:buFont typeface="Arial" panose="020B0604020202020204" pitchFamily="34" charset="0"/>
         <a:buChar char="•"/>
-        <a:defRPr sz="1772" kern="1200">
+        <a:defRPr sz="2268" kern="1200">
           <a:solidFill>
             <a:schemeClr val="tx1"/>
           </a:solidFill>
@@ -2761,16 +2766,16 @@
           <a:cs typeface="+mn-cs"/>
         </a:defRPr>
       </a:lvl4pPr>
-      <a:lvl5pPr marL="2024893" indent="-224988" algn="l" defTabSz="899952" rtl="0" eaLnBrk="1" latinLnBrk="0" hangingPunct="1">
+      <a:lvl5pPr marL="2592324" indent="-288036" algn="l" defTabSz="1152144" rtl="0" eaLnBrk="1" latinLnBrk="0" hangingPunct="1">
         <a:lnSpc>
           <a:spcPct val="90000"/>
         </a:lnSpc>
         <a:spcBef>
-          <a:spcPts val="492"/>
+          <a:spcPts val="630"/>
         </a:spcBef>
         <a:buFont typeface="Arial" panose="020B0604020202020204" pitchFamily="34" charset="0"/>
         <a:buChar char="•"/>
-        <a:defRPr sz="1772" kern="1200">
+        <a:defRPr sz="2268" kern="1200">
           <a:solidFill>
             <a:schemeClr val="tx1"/>
           </a:solidFill>
@@ -2779,16 +2784,16 @@
           <a:cs typeface="+mn-cs"/>
         </a:defRPr>
       </a:lvl5pPr>
-      <a:lvl6pPr marL="2474869" indent="-224988" algn="l" defTabSz="899952" rtl="0" eaLnBrk="1" latinLnBrk="0" hangingPunct="1">
+      <a:lvl6pPr marL="3168396" indent="-288036" algn="l" defTabSz="1152144" rtl="0" eaLnBrk="1" latinLnBrk="0" hangingPunct="1">
         <a:lnSpc>
           <a:spcPct val="90000"/>
         </a:lnSpc>
         <a:spcBef>
-          <a:spcPts val="492"/>
+          <a:spcPts val="630"/>
         </a:spcBef>
         <a:buFont typeface="Arial" panose="020B0604020202020204" pitchFamily="34" charset="0"/>
         <a:buChar char="•"/>
-        <a:defRPr sz="1772" kern="1200">
+        <a:defRPr sz="2268" kern="1200">
           <a:solidFill>
             <a:schemeClr val="tx1"/>
           </a:solidFill>
@@ -2797,16 +2802,16 @@
           <a:cs typeface="+mn-cs"/>
         </a:defRPr>
       </a:lvl6pPr>
-      <a:lvl7pPr marL="2924846" indent="-224988" algn="l" defTabSz="899952" rtl="0" eaLnBrk="1" latinLnBrk="0" hangingPunct="1">
+      <a:lvl7pPr marL="3744468" indent="-288036" algn="l" defTabSz="1152144" rtl="0" eaLnBrk="1" latinLnBrk="0" hangingPunct="1">
         <a:lnSpc>
           <a:spcPct val="90000"/>
         </a:lnSpc>
         <a:spcBef>
-          <a:spcPts val="492"/>
+          <a:spcPts val="630"/>
         </a:spcBef>
         <a:buFont typeface="Arial" panose="020B0604020202020204" pitchFamily="34" charset="0"/>
         <a:buChar char="•"/>
-        <a:defRPr sz="1772" kern="1200">
+        <a:defRPr sz="2268" kern="1200">
           <a:solidFill>
             <a:schemeClr val="tx1"/>
           </a:solidFill>
@@ -2815,16 +2820,16 @@
           <a:cs typeface="+mn-cs"/>
         </a:defRPr>
       </a:lvl7pPr>
-      <a:lvl8pPr marL="3374822" indent="-224988" algn="l" defTabSz="899952" rtl="0" eaLnBrk="1" latinLnBrk="0" hangingPunct="1">
+      <a:lvl8pPr marL="4320540" indent="-288036" algn="l" defTabSz="1152144" rtl="0" eaLnBrk="1" latinLnBrk="0" hangingPunct="1">
         <a:lnSpc>
           <a:spcPct val="90000"/>
         </a:lnSpc>
         <a:spcBef>
-          <a:spcPts val="492"/>
+          <a:spcPts val="630"/>
         </a:spcBef>
         <a:buFont typeface="Arial" panose="020B0604020202020204" pitchFamily="34" charset="0"/>
         <a:buChar char="•"/>
-        <a:defRPr sz="1772" kern="1200">
+        <a:defRPr sz="2268" kern="1200">
           <a:solidFill>
             <a:schemeClr val="tx1"/>
           </a:solidFill>
@@ -2833,16 +2838,16 @@
           <a:cs typeface="+mn-cs"/>
         </a:defRPr>
       </a:lvl8pPr>
-      <a:lvl9pPr marL="3824798" indent="-224988" algn="l" defTabSz="899952" rtl="0" eaLnBrk="1" latinLnBrk="0" hangingPunct="1">
+      <a:lvl9pPr marL="4896612" indent="-288036" algn="l" defTabSz="1152144" rtl="0" eaLnBrk="1" latinLnBrk="0" hangingPunct="1">
         <a:lnSpc>
           <a:spcPct val="90000"/>
         </a:lnSpc>
         <a:spcBef>
-          <a:spcPts val="492"/>
+          <a:spcPts val="630"/>
         </a:spcBef>
         <a:buFont typeface="Arial" panose="020B0604020202020204" pitchFamily="34" charset="0"/>
         <a:buChar char="•"/>
-        <a:defRPr sz="1772" kern="1200">
+        <a:defRPr sz="2268" kern="1200">
           <a:solidFill>
             <a:schemeClr val="tx1"/>
           </a:solidFill>
@@ -2856,8 +2861,8 @@
       <a:defPPr>
         <a:defRPr lang="en-US"/>
       </a:defPPr>
-      <a:lvl1pPr marL="0" algn="l" defTabSz="899952" rtl="0" eaLnBrk="1" latinLnBrk="0" hangingPunct="1">
-        <a:defRPr sz="1772" kern="1200">
+      <a:lvl1pPr marL="0" algn="l" defTabSz="1152144" rtl="0" eaLnBrk="1" latinLnBrk="0" hangingPunct="1">
+        <a:defRPr sz="2268" kern="1200">
           <a:solidFill>
             <a:schemeClr val="tx1"/>
           </a:solidFill>
@@ -2866,8 +2871,8 @@
           <a:cs typeface="+mn-cs"/>
         </a:defRPr>
       </a:lvl1pPr>
-      <a:lvl2pPr marL="449976" algn="l" defTabSz="899952" rtl="0" eaLnBrk="1" latinLnBrk="0" hangingPunct="1">
-        <a:defRPr sz="1772" kern="1200">
+      <a:lvl2pPr marL="576072" algn="l" defTabSz="1152144" rtl="0" eaLnBrk="1" latinLnBrk="0" hangingPunct="1">
+        <a:defRPr sz="2268" kern="1200">
           <a:solidFill>
             <a:schemeClr val="tx1"/>
           </a:solidFill>
@@ -2876,8 +2881,8 @@
           <a:cs typeface="+mn-cs"/>
         </a:defRPr>
       </a:lvl2pPr>
-      <a:lvl3pPr marL="899952" algn="l" defTabSz="899952" rtl="0" eaLnBrk="1" latinLnBrk="0" hangingPunct="1">
-        <a:defRPr sz="1772" kern="1200">
+      <a:lvl3pPr marL="1152144" algn="l" defTabSz="1152144" rtl="0" eaLnBrk="1" latinLnBrk="0" hangingPunct="1">
+        <a:defRPr sz="2268" kern="1200">
           <a:solidFill>
             <a:schemeClr val="tx1"/>
           </a:solidFill>
@@ -2886,8 +2891,8 @@
           <a:cs typeface="+mn-cs"/>
         </a:defRPr>
       </a:lvl3pPr>
-      <a:lvl4pPr marL="1349929" algn="l" defTabSz="899952" rtl="0" eaLnBrk="1" latinLnBrk="0" hangingPunct="1">
-        <a:defRPr sz="1772" kern="1200">
+      <a:lvl4pPr marL="1728216" algn="l" defTabSz="1152144" rtl="0" eaLnBrk="1" latinLnBrk="0" hangingPunct="1">
+        <a:defRPr sz="2268" kern="1200">
           <a:solidFill>
             <a:schemeClr val="tx1"/>
           </a:solidFill>
@@ -2896,8 +2901,8 @@
           <a:cs typeface="+mn-cs"/>
         </a:defRPr>
       </a:lvl4pPr>
-      <a:lvl5pPr marL="1799905" algn="l" defTabSz="899952" rtl="0" eaLnBrk="1" latinLnBrk="0" hangingPunct="1">
-        <a:defRPr sz="1772" kern="1200">
+      <a:lvl5pPr marL="2304288" algn="l" defTabSz="1152144" rtl="0" eaLnBrk="1" latinLnBrk="0" hangingPunct="1">
+        <a:defRPr sz="2268" kern="1200">
           <a:solidFill>
             <a:schemeClr val="tx1"/>
           </a:solidFill>
@@ -2906,8 +2911,8 @@
           <a:cs typeface="+mn-cs"/>
         </a:defRPr>
       </a:lvl5pPr>
-      <a:lvl6pPr marL="2249881" algn="l" defTabSz="899952" rtl="0" eaLnBrk="1" latinLnBrk="0" hangingPunct="1">
-        <a:defRPr sz="1772" kern="1200">
+      <a:lvl6pPr marL="2880360" algn="l" defTabSz="1152144" rtl="0" eaLnBrk="1" latinLnBrk="0" hangingPunct="1">
+        <a:defRPr sz="2268" kern="1200">
           <a:solidFill>
             <a:schemeClr val="tx1"/>
           </a:solidFill>
@@ -2916,8 +2921,8 @@
           <a:cs typeface="+mn-cs"/>
         </a:defRPr>
       </a:lvl6pPr>
-      <a:lvl7pPr marL="2699857" algn="l" defTabSz="899952" rtl="0" eaLnBrk="1" latinLnBrk="0" hangingPunct="1">
-        <a:defRPr sz="1772" kern="1200">
+      <a:lvl7pPr marL="3456432" algn="l" defTabSz="1152144" rtl="0" eaLnBrk="1" latinLnBrk="0" hangingPunct="1">
+        <a:defRPr sz="2268" kern="1200">
           <a:solidFill>
             <a:schemeClr val="tx1"/>
           </a:solidFill>
@@ -2926,8 +2931,8 @@
           <a:cs typeface="+mn-cs"/>
         </a:defRPr>
       </a:lvl7pPr>
-      <a:lvl8pPr marL="3149834" algn="l" defTabSz="899952" rtl="0" eaLnBrk="1" latinLnBrk="0" hangingPunct="1">
-        <a:defRPr sz="1772" kern="1200">
+      <a:lvl8pPr marL="4032504" algn="l" defTabSz="1152144" rtl="0" eaLnBrk="1" latinLnBrk="0" hangingPunct="1">
+        <a:defRPr sz="2268" kern="1200">
           <a:solidFill>
             <a:schemeClr val="tx1"/>
           </a:solidFill>
@@ -2936,8 +2941,8 @@
           <a:cs typeface="+mn-cs"/>
         </a:defRPr>
       </a:lvl8pPr>
-      <a:lvl9pPr marL="3599810" algn="l" defTabSz="899952" rtl="0" eaLnBrk="1" latinLnBrk="0" hangingPunct="1">
-        <a:defRPr sz="1772" kern="1200">
+      <a:lvl9pPr marL="4608576" algn="l" defTabSz="1152144" rtl="0" eaLnBrk="1" latinLnBrk="0" hangingPunct="1">
+        <a:defRPr sz="2268" kern="1200">
           <a:solidFill>
             <a:schemeClr val="tx1"/>
           </a:solidFill>
@@ -2968,12 +2973,61 @@
           <a:chExt cx="0" cy="0"/>
         </a:xfrm>
       </p:grpSpPr>
+      <p:sp>
+        <p:nvSpPr>
+          <p:cNvPr id="14" name="Rectangle 13">
+            <a:extLst>
+              <a:ext uri="{FF2B5EF4-FFF2-40B4-BE49-F238E27FC236}">
+                <a16:creationId xmlns:a16="http://schemas.microsoft.com/office/drawing/2014/main" id="{49301E68-2658-FC28-9ED9-D6061D4528E1}"/>
+              </a:ext>
+            </a:extLst>
+          </p:cNvPr>
+          <p:cNvSpPr/>
+          <p:nvPr/>
+        </p:nvSpPr>
+        <p:spPr>
+          <a:xfrm>
+            <a:off x="645459" y="472738"/>
+            <a:ext cx="11833412" cy="2337697"/>
+          </a:xfrm>
+          <a:prstGeom prst="rect">
+            <a:avLst/>
+          </a:prstGeom>
+          <a:solidFill>
+            <a:schemeClr val="bg1"/>
+          </a:solidFill>
+        </p:spPr>
+        <p:style>
+          <a:lnRef idx="2">
+            <a:schemeClr val="accent1">
+              <a:shade val="15000"/>
+            </a:schemeClr>
+          </a:lnRef>
+          <a:fillRef idx="1">
+            <a:schemeClr val="accent1"/>
+          </a:fillRef>
+          <a:effectRef idx="0">
+            <a:schemeClr val="accent1"/>
+          </a:effectRef>
+          <a:fontRef idx="minor">
+            <a:schemeClr val="lt1"/>
+          </a:fontRef>
+        </p:style>
+        <p:txBody>
+          <a:bodyPr rtlCol="0" anchor="ctr"/>
+          <a:lstStyle/>
+          <a:p>
+            <a:pPr algn="ctr"/>
+            <a:endParaRPr lang="en-US"/>
+          </a:p>
+        </p:txBody>
+      </p:sp>
       <p:pic>
         <p:nvPicPr>
-          <p:cNvPr id="27" name="Picture 26">
+          <p:cNvPr id="2" name="Picture 1">
             <a:extLst>
               <a:ext uri="{FF2B5EF4-FFF2-40B4-BE49-F238E27FC236}">
-                <a16:creationId xmlns:a16="http://schemas.microsoft.com/office/drawing/2014/main" id="{8771815F-6A10-F511-1657-1C23738A1401}"/>
+                <a16:creationId xmlns:a16="http://schemas.microsoft.com/office/drawing/2014/main" id="{106D20F2-029E-DCFC-22C3-D28BB1D03C9D}"/>
               </a:ext>
             </a:extLst>
           </p:cNvPr>
@@ -2990,7 +3044,7 @@
         </p:blipFill>
         <p:spPr>
           <a:xfrm>
-            <a:off x="312204" y="29817"/>
+            <a:off x="283714" y="3088114"/>
             <a:ext cx="4244546" cy="2829697"/>
           </a:xfrm>
           <a:prstGeom prst="rect">
@@ -3000,10 +3054,10 @@
       </p:pic>
       <p:pic>
         <p:nvPicPr>
-          <p:cNvPr id="28" name="Picture 27">
+          <p:cNvPr id="3" name="Picture 2">
             <a:extLst>
               <a:ext uri="{FF2B5EF4-FFF2-40B4-BE49-F238E27FC236}">
-                <a16:creationId xmlns:a16="http://schemas.microsoft.com/office/drawing/2014/main" id="{A5FF01BD-BD02-5E40-297D-A5BFA1475F9B}"/>
+                <a16:creationId xmlns:a16="http://schemas.microsoft.com/office/drawing/2014/main" id="{520AB600-93FB-DCD6-2AD8-6FFF6C580DDA}"/>
               </a:ext>
             </a:extLst>
           </p:cNvPr>
@@ -3020,7 +3074,7 @@
         </p:blipFill>
         <p:spPr>
           <a:xfrm>
-            <a:off x="4556751" y="29817"/>
+            <a:off x="4613731" y="3032531"/>
             <a:ext cx="4244546" cy="2829697"/>
           </a:xfrm>
           <a:prstGeom prst="rect">
@@ -3030,10 +3084,10 @@
       </p:pic>
       <p:pic>
         <p:nvPicPr>
-          <p:cNvPr id="29" name="Picture 28">
+          <p:cNvPr id="4" name="Picture 3">
             <a:extLst>
               <a:ext uri="{FF2B5EF4-FFF2-40B4-BE49-F238E27FC236}">
-                <a16:creationId xmlns:a16="http://schemas.microsoft.com/office/drawing/2014/main" id="{3E72F069-27A7-EF88-AC72-C5E4B2D8C053}"/>
+                <a16:creationId xmlns:a16="http://schemas.microsoft.com/office/drawing/2014/main" id="{58282DE1-B4F2-5BA8-4C69-9CA0E7916BDF}"/>
               </a:ext>
             </a:extLst>
           </p:cNvPr>
@@ -3050,7 +3104,7 @@
         </p:blipFill>
         <p:spPr>
           <a:xfrm>
-            <a:off x="312204" y="2859514"/>
+            <a:off x="8801296" y="3088114"/>
             <a:ext cx="4244546" cy="2829697"/>
           </a:xfrm>
           <a:prstGeom prst="rect">
@@ -3060,10 +3114,10 @@
       </p:pic>
       <p:pic>
         <p:nvPicPr>
-          <p:cNvPr id="30" name="Picture 29">
+          <p:cNvPr id="5" name="Picture 4">
             <a:extLst>
               <a:ext uri="{FF2B5EF4-FFF2-40B4-BE49-F238E27FC236}">
-                <a16:creationId xmlns:a16="http://schemas.microsoft.com/office/drawing/2014/main" id="{54F8FEAC-953B-EF98-FAF6-F839C74EBD64}"/>
+                <a16:creationId xmlns:a16="http://schemas.microsoft.com/office/drawing/2014/main" id="{A9A55AB3-D076-2483-B832-4A77F7CAB00C}"/>
               </a:ext>
             </a:extLst>
           </p:cNvPr>
@@ -3080,7 +3134,7 @@
         </p:blipFill>
         <p:spPr>
           <a:xfrm>
-            <a:off x="4499769" y="2920441"/>
+            <a:off x="312204" y="5811066"/>
             <a:ext cx="4244546" cy="2829697"/>
           </a:xfrm>
           <a:prstGeom prst="rect">
@@ -3090,10 +3144,10 @@
       </p:pic>
       <p:pic>
         <p:nvPicPr>
-          <p:cNvPr id="31" name="Picture 30">
+          <p:cNvPr id="6" name="Picture 5">
             <a:extLst>
               <a:ext uri="{FF2B5EF4-FFF2-40B4-BE49-F238E27FC236}">
-                <a16:creationId xmlns:a16="http://schemas.microsoft.com/office/drawing/2014/main" id="{31B42E51-A32D-F1C4-0995-58B4049217C7}"/>
+                <a16:creationId xmlns:a16="http://schemas.microsoft.com/office/drawing/2014/main" id="{322755DE-40EC-46E2-6F43-00D4DAF66F29}"/>
               </a:ext>
             </a:extLst>
           </p:cNvPr>
@@ -3110,7 +3164,7 @@
         </p:blipFill>
         <p:spPr>
           <a:xfrm>
-            <a:off x="312204" y="5811066"/>
+            <a:off x="4613731" y="5811065"/>
             <a:ext cx="4244546" cy="2829697"/>
           </a:xfrm>
           <a:prstGeom prst="rect">
@@ -3118,6 +3172,445 @@
           </a:prstGeom>
         </p:spPr>
       </p:pic>
+      <p:pic>
+        <p:nvPicPr>
+          <p:cNvPr id="7" name="Picture 6" descr="A diagram of a line and a line&#10;&#10;AI-generated content may be incorrect.">
+            <a:extLst>
+              <a:ext uri="{FF2B5EF4-FFF2-40B4-BE49-F238E27FC236}">
+                <a16:creationId xmlns:a16="http://schemas.microsoft.com/office/drawing/2014/main" id="{8C3ED990-5567-7F3C-6167-016C1DA1BF6D}"/>
+              </a:ext>
+            </a:extLst>
+          </p:cNvPr>
+          <p:cNvPicPr>
+            <a:picLocks noChangeAspect="1"/>
+          </p:cNvPicPr>
+          <p:nvPr/>
+        </p:nvPicPr>
+        <p:blipFill>
+          <a:blip r:embed="rId7"/>
+          <a:stretch>
+            <a:fillRect/>
+          </a:stretch>
+        </p:blipFill>
+        <p:spPr>
+          <a:xfrm>
+            <a:off x="1315144" y="503035"/>
+            <a:ext cx="1079500" cy="1079500"/>
+          </a:xfrm>
+          <a:prstGeom prst="rect">
+            <a:avLst/>
+          </a:prstGeom>
+        </p:spPr>
+      </p:pic>
+      <p:pic>
+        <p:nvPicPr>
+          <p:cNvPr id="8" name="Picture 7" descr="A diagram of a line with arrows&#10;&#10;AI-generated content may be incorrect.">
+            <a:extLst>
+              <a:ext uri="{FF2B5EF4-FFF2-40B4-BE49-F238E27FC236}">
+                <a16:creationId xmlns:a16="http://schemas.microsoft.com/office/drawing/2014/main" id="{D099AF8A-124C-4A43-5966-BF4CEBE4EECA}"/>
+              </a:ext>
+            </a:extLst>
+          </p:cNvPr>
+          <p:cNvPicPr>
+            <a:picLocks noChangeAspect="1"/>
+          </p:cNvPicPr>
+          <p:nvPr/>
+        </p:nvPicPr>
+        <p:blipFill>
+          <a:blip r:embed="rId8"/>
+          <a:stretch>
+            <a:fillRect/>
+          </a:stretch>
+        </p:blipFill>
+        <p:spPr>
+          <a:xfrm>
+            <a:off x="2835190" y="499076"/>
+            <a:ext cx="1079500" cy="1079500"/>
+          </a:xfrm>
+          <a:prstGeom prst="rect">
+            <a:avLst/>
+          </a:prstGeom>
+        </p:spPr>
+      </p:pic>
+      <p:pic>
+        <p:nvPicPr>
+          <p:cNvPr id="9" name="Picture 8" descr="A diagram of a line with arrows&#10;&#10;AI-generated content may be incorrect.">
+            <a:extLst>
+              <a:ext uri="{FF2B5EF4-FFF2-40B4-BE49-F238E27FC236}">
+                <a16:creationId xmlns:a16="http://schemas.microsoft.com/office/drawing/2014/main" id="{8355A04D-36E1-D59D-C042-1EEB57D5B306}"/>
+              </a:ext>
+            </a:extLst>
+          </p:cNvPr>
+          <p:cNvPicPr>
+            <a:picLocks noChangeAspect="1"/>
+          </p:cNvPicPr>
+          <p:nvPr/>
+        </p:nvPicPr>
+        <p:blipFill>
+          <a:blip r:embed="rId9"/>
+          <a:stretch>
+            <a:fillRect/>
+          </a:stretch>
+        </p:blipFill>
+        <p:spPr>
+          <a:xfrm>
+            <a:off x="4641824" y="499076"/>
+            <a:ext cx="1079500" cy="1079500"/>
+          </a:xfrm>
+          <a:prstGeom prst="rect">
+            <a:avLst/>
+          </a:prstGeom>
+        </p:spPr>
+      </p:pic>
+      <p:pic>
+        <p:nvPicPr>
+          <p:cNvPr id="10" name="Picture 9" descr="A diagram of a square with arrows&#10;&#10;AI-generated content may be incorrect.">
+            <a:extLst>
+              <a:ext uri="{FF2B5EF4-FFF2-40B4-BE49-F238E27FC236}">
+                <a16:creationId xmlns:a16="http://schemas.microsoft.com/office/drawing/2014/main" id="{E243F042-E1F9-8571-3369-C2788C5EFBAE}"/>
+              </a:ext>
+            </a:extLst>
+          </p:cNvPr>
+          <p:cNvPicPr>
+            <a:picLocks noChangeAspect="1"/>
+          </p:cNvPicPr>
+          <p:nvPr/>
+        </p:nvPicPr>
+        <p:blipFill>
+          <a:blip r:embed="rId10"/>
+          <a:stretch>
+            <a:fillRect/>
+          </a:stretch>
+        </p:blipFill>
+        <p:spPr>
+          <a:xfrm>
+            <a:off x="6448458" y="499076"/>
+            <a:ext cx="1079500" cy="1079500"/>
+          </a:xfrm>
+          <a:prstGeom prst="rect">
+            <a:avLst/>
+          </a:prstGeom>
+        </p:spPr>
+      </p:pic>
+      <p:pic>
+        <p:nvPicPr>
+          <p:cNvPr id="11" name="Picture 10" descr="A diagram of a line with arrows&#10;&#10;AI-generated content may be incorrect.">
+            <a:extLst>
+              <a:ext uri="{FF2B5EF4-FFF2-40B4-BE49-F238E27FC236}">
+                <a16:creationId xmlns:a16="http://schemas.microsoft.com/office/drawing/2014/main" id="{F0220976-C054-57B3-B203-A33D55E7E2DE}"/>
+              </a:ext>
+            </a:extLst>
+          </p:cNvPr>
+          <p:cNvPicPr>
+            <a:picLocks noChangeAspect="1"/>
+          </p:cNvPicPr>
+          <p:nvPr/>
+        </p:nvPicPr>
+        <p:blipFill>
+          <a:blip r:embed="rId11"/>
+          <a:stretch>
+            <a:fillRect/>
+          </a:stretch>
+        </p:blipFill>
+        <p:spPr>
+          <a:xfrm>
+            <a:off x="8255092" y="499076"/>
+            <a:ext cx="1079500" cy="1079500"/>
+          </a:xfrm>
+          <a:prstGeom prst="rect">
+            <a:avLst/>
+          </a:prstGeom>
+        </p:spPr>
+      </p:pic>
+      <p:sp>
+        <p:nvSpPr>
+          <p:cNvPr id="13" name="TextBox 12">
+            <a:extLst>
+              <a:ext uri="{FF2B5EF4-FFF2-40B4-BE49-F238E27FC236}">
+                <a16:creationId xmlns:a16="http://schemas.microsoft.com/office/drawing/2014/main" id="{6E411B07-FD69-DE7E-6D2B-5375FD1890EB}"/>
+              </a:ext>
+            </a:extLst>
+          </p:cNvPr>
+          <p:cNvSpPr txBox="1"/>
+          <p:nvPr/>
+        </p:nvSpPr>
+        <p:spPr>
+          <a:xfrm>
+            <a:off x="874597" y="1592023"/>
+            <a:ext cx="11232302" cy="1384995"/>
+          </a:xfrm>
+          <a:prstGeom prst="rect">
+            <a:avLst/>
+          </a:prstGeom>
+          <a:noFill/>
+        </p:spPr>
+        <p:txBody>
+          <a:bodyPr wrap="square">
+            <a:spAutoFit/>
+          </a:bodyPr>
+          <a:lstStyle/>
+          <a:p>
+            <a:pPr marL="285750" lvl="2" indent="-285750">
+              <a:buFont typeface="Arial" panose="020B0604020202020204" pitchFamily="34" charset="0"/>
+              <a:buChar char="•"/>
+            </a:pPr>
+            <a:r>
+              <a:rPr lang="en-CA" sz="1400" b="1" dirty="0"/>
+              <a:t>Category 1</a:t>
+            </a:r>
+            <a:r>
+              <a:rPr lang="en-CA" sz="1400" dirty="0"/>
+              <a:t>: tumour growth </a:t>
+            </a:r>
+            <a:r>
+              <a:rPr lang="en-CA" sz="1400" b="1" dirty="0"/>
+              <a:t>similar to control</a:t>
+            </a:r>
+            <a:r>
+              <a:rPr lang="en-CA" sz="1400" dirty="0"/>
+              <a:t>.</a:t>
+            </a:r>
+          </a:p>
+          <a:p>
+            <a:pPr marL="285750" lvl="2" indent="-285750">
+              <a:buFont typeface="Arial" panose="020B0604020202020204" pitchFamily="34" charset="0"/>
+              <a:buChar char="•"/>
+            </a:pPr>
+            <a:r>
+              <a:rPr lang="en-CA" sz="1400" b="1" dirty="0"/>
+              <a:t>Category 2</a:t>
+            </a:r>
+            <a:r>
+              <a:rPr lang="en-CA" sz="1400" dirty="0"/>
+              <a:t>: tumour growth is </a:t>
+            </a:r>
+            <a:r>
+              <a:rPr lang="en-CA" sz="1400" b="1" dirty="0"/>
+              <a:t>inhibited compared to control</a:t>
+            </a:r>
+            <a:r>
+              <a:rPr lang="en-CA" sz="1400" dirty="0"/>
+              <a:t>, but tumour is still </a:t>
+            </a:r>
+            <a:r>
+              <a:rPr lang="en-CA" sz="1400" b="1" dirty="0"/>
+              <a:t>enlarging</a:t>
+            </a:r>
+            <a:r>
+              <a:rPr lang="en-CA" sz="1400" dirty="0"/>
+              <a:t> compared to time 0.</a:t>
+            </a:r>
+          </a:p>
+          <a:p>
+            <a:pPr marL="285750" lvl="2" indent="-285750">
+              <a:buFont typeface="Arial" panose="020B0604020202020204" pitchFamily="34" charset="0"/>
+              <a:buChar char="•"/>
+            </a:pPr>
+            <a:r>
+              <a:rPr lang="en-CA" sz="1400" b="1" dirty="0"/>
+              <a:t>Category 3</a:t>
+            </a:r>
+            <a:r>
+              <a:rPr lang="en-CA" sz="1400" dirty="0"/>
+              <a:t>: tumour growth is </a:t>
+            </a:r>
+            <a:r>
+              <a:rPr lang="en-CA" sz="1400" b="1" dirty="0"/>
+              <a:t>inhibited compared to control</a:t>
+            </a:r>
+            <a:r>
+              <a:rPr lang="en-CA" sz="1400" dirty="0"/>
+              <a:t>, and tumour volume stays </a:t>
+            </a:r>
+            <a:r>
+              <a:rPr lang="en-CA" sz="1400" b="1" dirty="0"/>
+              <a:t>stable</a:t>
+            </a:r>
+            <a:r>
+              <a:rPr lang="en-CA" sz="1400" dirty="0"/>
+              <a:t>.</a:t>
+            </a:r>
+          </a:p>
+          <a:p>
+            <a:pPr marL="285750" lvl="2" indent="-285750">
+              <a:buFont typeface="Arial" panose="020B0604020202020204" pitchFamily="34" charset="0"/>
+              <a:buChar char="•"/>
+            </a:pPr>
+            <a:r>
+              <a:rPr lang="en-CA" sz="1400" b="1" dirty="0"/>
+              <a:t>Category 4</a:t>
+            </a:r>
+            <a:r>
+              <a:rPr lang="en-CA" sz="1400" dirty="0"/>
+              <a:t>: tumour growth is </a:t>
+            </a:r>
+            <a:r>
+              <a:rPr lang="en-CA" sz="1400" b="1" dirty="0"/>
+              <a:t>inhibited compared to control</a:t>
+            </a:r>
+            <a:r>
+              <a:rPr lang="en-CA" sz="1400" dirty="0"/>
+              <a:t>, and tumour volume is </a:t>
+            </a:r>
+            <a:r>
+              <a:rPr lang="en-CA" sz="1400" b="1" dirty="0"/>
+              <a:t>shrinking</a:t>
+            </a:r>
+            <a:r>
+              <a:rPr lang="en-CA" sz="1400" dirty="0"/>
+              <a:t>.</a:t>
+            </a:r>
+          </a:p>
+          <a:p>
+            <a:pPr marL="285750" lvl="2" indent="-285750">
+              <a:buFont typeface="Arial" panose="020B0604020202020204" pitchFamily="34" charset="0"/>
+              <a:buChar char="•"/>
+            </a:pPr>
+            <a:r>
+              <a:rPr lang="en-CA" sz="1400" b="1" dirty="0"/>
+              <a:t>Category 5</a:t>
+            </a:r>
+            <a:r>
+              <a:rPr lang="en-CA" sz="1400" dirty="0"/>
+              <a:t>: tumour growth is </a:t>
+            </a:r>
+            <a:r>
+              <a:rPr lang="en-CA" sz="1400" b="1" dirty="0"/>
+              <a:t>inhibited compared to control</a:t>
+            </a:r>
+            <a:r>
+              <a:rPr lang="en-CA" sz="1400" dirty="0"/>
+              <a:t>, and tumour </a:t>
+            </a:r>
+            <a:r>
+              <a:rPr lang="en-CA" sz="1400" b="1" dirty="0"/>
+              <a:t>disappeared</a:t>
+            </a:r>
+            <a:r>
+              <a:rPr lang="en-CA" sz="1400" dirty="0"/>
+              <a:t> during treatment.</a:t>
+            </a:r>
+            <a:br>
+              <a:rPr lang="en-CA" sz="1400" dirty="0"/>
+            </a:br>
+            <a:endParaRPr lang="en-US" sz="1400" dirty="0"/>
+          </a:p>
+        </p:txBody>
+      </p:sp>
+      <p:sp>
+        <p:nvSpPr>
+          <p:cNvPr id="15" name="TextBox 14">
+            <a:extLst>
+              <a:ext uri="{FF2B5EF4-FFF2-40B4-BE49-F238E27FC236}">
+                <a16:creationId xmlns:a16="http://schemas.microsoft.com/office/drawing/2014/main" id="{B5381927-DCEA-91BA-B0D1-9518DE6D9AC6}"/>
+              </a:ext>
+            </a:extLst>
+          </p:cNvPr>
+          <p:cNvSpPr txBox="1"/>
+          <p:nvPr/>
+        </p:nvSpPr>
+        <p:spPr>
+          <a:xfrm>
+            <a:off x="103436" y="3031498"/>
+            <a:ext cx="645459" cy="369332"/>
+          </a:xfrm>
+          <a:prstGeom prst="rect">
+            <a:avLst/>
+          </a:prstGeom>
+          <a:noFill/>
+        </p:spPr>
+        <p:txBody>
+          <a:bodyPr wrap="square" rtlCol="0">
+            <a:spAutoFit/>
+          </a:bodyPr>
+          <a:lstStyle/>
+          <a:p>
+            <a:r>
+              <a:rPr lang="en-US" dirty="0"/>
+              <a:t>b</a:t>
+            </a:r>
+          </a:p>
+        </p:txBody>
+      </p:sp>
+      <p:sp>
+        <p:nvSpPr>
+          <p:cNvPr id="16" name="TextBox 15">
+            <a:extLst>
+              <a:ext uri="{FF2B5EF4-FFF2-40B4-BE49-F238E27FC236}">
+                <a16:creationId xmlns:a16="http://schemas.microsoft.com/office/drawing/2014/main" id="{6C4B2921-2C22-BC2E-39D8-F901E91E7B0A}"/>
+              </a:ext>
+            </a:extLst>
+          </p:cNvPr>
+          <p:cNvSpPr txBox="1"/>
+          <p:nvPr/>
+        </p:nvSpPr>
+        <p:spPr>
+          <a:xfrm>
+            <a:off x="51718" y="-7125"/>
+            <a:ext cx="645459" cy="369332"/>
+          </a:xfrm>
+          <a:prstGeom prst="rect">
+            <a:avLst/>
+          </a:prstGeom>
+          <a:noFill/>
+        </p:spPr>
+        <p:txBody>
+          <a:bodyPr wrap="square" rtlCol="0">
+            <a:spAutoFit/>
+          </a:bodyPr>
+          <a:lstStyle/>
+          <a:p>
+            <a:r>
+              <a:rPr lang="en-US" dirty="0"/>
+              <a:t>a</a:t>
+            </a:r>
+          </a:p>
+        </p:txBody>
+      </p:sp>
+      <p:sp>
+        <p:nvSpPr>
+          <p:cNvPr id="17" name="TextBox 16">
+            <a:extLst>
+              <a:ext uri="{FF2B5EF4-FFF2-40B4-BE49-F238E27FC236}">
+                <a16:creationId xmlns:a16="http://schemas.microsoft.com/office/drawing/2014/main" id="{7A9C7928-EA86-7768-97ED-E355E65B01FE}"/>
+              </a:ext>
+            </a:extLst>
+          </p:cNvPr>
+          <p:cNvSpPr txBox="1"/>
+          <p:nvPr/>
+        </p:nvSpPr>
+        <p:spPr>
+          <a:xfrm>
+            <a:off x="748895" y="107576"/>
+            <a:ext cx="9134693" cy="369332"/>
+          </a:xfrm>
+          <a:prstGeom prst="rect">
+            <a:avLst/>
+          </a:prstGeom>
+          <a:noFill/>
+        </p:spPr>
+        <p:txBody>
+          <a:bodyPr wrap="square" rtlCol="0">
+            <a:spAutoFit/>
+          </a:bodyPr>
+          <a:lstStyle/>
+          <a:p>
+            <a:r>
+              <a:rPr lang="en-US"/>
+              <a:t>Drug sensitivity categorization criteria </a:t>
+            </a:r>
+            <a:r>
+              <a:rPr lang="en-US" dirty="0"/>
+              <a:t>p</a:t>
+            </a:r>
+            <a:r>
+              <a:rPr lang="en-US"/>
+              <a:t>rovided to panel of experts </a:t>
+            </a:r>
+            <a:endParaRPr lang="en-US" dirty="0"/>
+          </a:p>
+        </p:txBody>
+      </p:sp>
     </p:spTree>
     <p:extLst>
       <p:ext uri="{BB962C8B-B14F-4D97-AF65-F5344CB8AC3E}">

</xml_diff>